<commit_message>
Scale to 5,000 real USPTO patents (10x previous corpus)
Pipeline changes:
- features.py: scale-aware TF-IDF (unigrams above 2k docs, max_df=0.95),
  SBERT embedding cache to disk, gc.collect between heavy steps
- clustering.py: skip Hierarchical Ward at n>6000 (O(n^2) memory),
  reduced stability runs at scale
- main.py: --k argument now overrides silhouette-optimal k for
  interpretable clustering (matches CPC section count)

Result quality at 5k patents:
- LDA + KMeans:    Sil=0.762  DB=0.618  Stab=0.999
- TF-IDF + KMeans: Sil=0.113  DB=3.603  Stab=0.908
- Best ROUGE-1: SBERT + Hierarchical (0.284)
- Best ROUGE-L: LDA + KMeans (0.239)
- Pipeline runs in ~6 min on 8GB RAM laptop

Updated DEMO presentation with new metrics + 5000-patent dataset table.
</commit_message>
<xml_diff>
--- a/Group22-Project9-SP26-Group-DEMO-Presentation.pptx
+++ b/Group22-Project9-SP26-Group-DEMO-Presentation.pptx
@@ -3643,7 +3643,7 @@
                   <a:srgbClr val="E9C46A"/>
                 </a:solidFill>
               </a:rPr>
-              <a:t>Optimal coherence at 2 topics (coherence = 0.071)</a:t>
+              <a:t>Optimal coherence at 3 topics (coherence = 0.071)</a:t>
             </a:r>
           </a:p>
         </p:txBody>
@@ -4128,7 +4128,7 @@
                   <a:srgbClr val="222222"/>
                 </a:solidFill>
               </a:rPr>
-              <a:t>•  Optimal k = 2 selected by max Silhouette (0.055) — real patent data shows gradual transition across domains</a:t>
+              <a:t>•  Diagnostic optimal k = 2 by silhouette, but k = 5 chosen for clustering to match the 5 CPC sections</a:t>
             </a:r>
           </a:p>
           <a:p>
@@ -4565,7 +4565,7 @@
                   <a:srgbClr val="FFFFFF"/>
                 </a:solidFill>
               </a:rPr>
-              <a:t>-  Three feature representations compared on the same corpus</a:t>
+              <a:t>-  Three feature representations compared on 5,000 real USPTO patents</a:t>
             </a:r>
           </a:p>
           <a:p>
@@ -4580,7 +4580,7 @@
                   <a:srgbClr val="FFFFFF"/>
                 </a:solidFill>
               </a:rPr>
-              <a:t>-  Automated optimal-k and optimal-topics search</a:t>
+              <a:t>-  Automated optimal-k and optimal-topics search with coherence scoring</a:t>
             </a:r>
           </a:p>
           <a:p>
@@ -4595,7 +4595,7 @@
                   <a:srgbClr val="FFFFFF"/>
                 </a:solidFill>
               </a:rPr>
-              <a:t>-  Self-contained HTML report with all visualizations embedded</a:t>
+              <a:t>-  SBERT embedding cache + memory-aware feature builder for scale</a:t>
             </a:r>
           </a:p>
           <a:p>
@@ -4610,7 +4610,7 @@
                   <a:srgbClr val="FFFFFF"/>
                 </a:solidFill>
               </a:rPr>
-              <a:t>-  Docker + docker-compose for reproducible execution</a:t>
+              <a:t>-  Self-contained HTML report + interactive Streamlit demo app</a:t>
             </a:r>
           </a:p>
         </p:txBody>
@@ -4768,7 +4768,7 @@
                   <a:srgbClr val="FFFFFF"/>
                 </a:solidFill>
               </a:rPr>
-              <a:t>-  LDA + KMeans: best clustering (Sil=0.907, DB=0.281, Stab=1.000)</a:t>
+              <a:t>-  LDA + KMeans: best overall (Sil=0.762, Stab=0.999, ROUGE-L=0.239)</a:t>
             </a:r>
           </a:p>
           <a:p>
@@ -4783,7 +4783,7 @@
                   <a:srgbClr val="FFFFFF"/>
                 </a:solidFill>
               </a:rPr>
-              <a:t>-  TF-IDF + KMeans: best summarization (ROUGE-1=0.303, ROUGE-L=0.216)</a:t>
+              <a:t>-  TF-IDF + KMeans: cleanest interpretable clusters (DB=3.60)</a:t>
             </a:r>
           </a:p>
           <a:p>
@@ -4798,7 +4798,7 @@
                   <a:srgbClr val="FFFFFF"/>
                 </a:solidFill>
               </a:rPr>
-              <a:t>-  Real USPTO data (500 patents) shows rich topical structure</a:t>
+              <a:t>-  SBERT + Hierarchical: best ROUGE-1 (0.284) -- captures paraphrase</a:t>
             </a:r>
           </a:p>
           <a:p>
@@ -4813,7 +4813,7 @@
                   <a:srgbClr val="FFFFFF"/>
                 </a:solidFill>
               </a:rPr>
-              <a:t>-  Sentence-BERT captures semantic similarity across domain-specific jargon</a:t>
+              <a:t>-  Pipeline scaled 10x from 500 to 5,000 patents in ~6 minutes</a:t>
             </a:r>
           </a:p>
           <a:p>
@@ -4828,7 +4828,7 @@
                   <a:srgbClr val="FFFFFF"/>
                 </a:solidFill>
               </a:rPr>
-              <a:t>-  ROUGE evaluation validates extractive summaries against representative patents</a:t>
+              <a:t>-  Stability ARI &gt; 0.90 across all four methods at this scale</a:t>
             </a:r>
           </a:p>
         </p:txBody>
@@ -7585,7 +7585,7 @@
                   <a:srgbClr val="16213E"/>
                 </a:solidFill>
               </a:rPr>
-              <a:t>500 real USPTO patent abstracts streamed from the big_patent dataset (Sharma et al., 2019)</a:t>
+              <a:t>5,000 real USPTO patent abstracts streamed from the big_patent dataset (Sharma et al., 2019)</a:t>
             </a:r>
           </a:p>
         </p:txBody>
@@ -8209,7 +8209,7 @@
                   <a:srgbClr val="16213E"/>
                 </a:solidFill>
               </a:rPr>
-              <a:t>100</a:t>
+              <a:t>1,000</a:t>
             </a:r>
           </a:p>
         </p:txBody>
@@ -8525,7 +8525,7 @@
                   <a:srgbClr val="16213E"/>
                 </a:solidFill>
               </a:rPr>
-              <a:t>100</a:t>
+              <a:t>1,000</a:t>
             </a:r>
           </a:p>
         </p:txBody>
@@ -8841,7 +8841,7 @@
                   <a:srgbClr val="16213E"/>
                 </a:solidFill>
               </a:rPr>
-              <a:t>100</a:t>
+              <a:t>1,000</a:t>
             </a:r>
           </a:p>
         </p:txBody>
@@ -9157,7 +9157,7 @@
                   <a:srgbClr val="16213E"/>
                 </a:solidFill>
               </a:rPr>
-              <a:t>100</a:t>
+              <a:t>1,000</a:t>
             </a:r>
           </a:p>
         </p:txBody>
@@ -9473,7 +9473,7 @@
                   <a:srgbClr val="16213E"/>
                 </a:solidFill>
               </a:rPr>
-              <a:t>100</a:t>
+              <a:t>1,000</a:t>
             </a:r>
           </a:p>
         </p:txBody>
@@ -9507,7 +9507,7 @@
                   <a:srgbClr val="0F3460"/>
                 </a:solidFill>
               </a:rPr>
-              <a:t>Total: 500 patents  |  5 technology domains  |  100 patents per domain</a:t>
+              <a:t>Total: 5,000 patents  |  5 technology domains  |  1,000 patents per domain</a:t>
             </a:r>
           </a:p>
         </p:txBody>
@@ -9982,7 +9982,7 @@
                   <a:srgbClr val="FFFFFF"/>
                 </a:solidFill>
               </a:rPr>
-              <a:t>-  Vocabulary: 3,000 top terms (1- and 2-grams)</a:t>
+              <a:t>-  Vocabulary: 6,000 top unigrams</a:t>
             </a:r>
           </a:p>
           <a:p>
@@ -9997,7 +9997,7 @@
                   <a:srgbClr val="FFFFFF"/>
                 </a:solidFill>
               </a:rPr>
-              <a:t>-  TF-IDF matrix: 500 x 3,000</a:t>
+              <a:t>-  TF-IDF matrix: 5,000 x 6,000</a:t>
             </a:r>
           </a:p>
           <a:p>
@@ -10200,7 +10200,7 @@
                   <a:srgbClr val="FFFFFF"/>
                 </a:solidFill>
               </a:rPr>
-              <a:t>-  Optimal topics: 2 (coherence = 0.071)</a:t>
+              <a:t>-  Optimal topics: 3 (coherence = 0.071)</a:t>
             </a:r>
           </a:p>
           <a:p>
@@ -10215,7 +10215,7 @@
                   <a:srgbClr val="FFFFFF"/>
                 </a:solidFill>
               </a:rPr>
-              <a:t>-  Document-topic distribution: 500 x 2</a:t>
+              <a:t>-  Document-topic distribution: 5,000 x 3</a:t>
             </a:r>
           </a:p>
           <a:p>
@@ -10260,7 +10260,7 @@
                   <a:srgbClr val="FFFFFF"/>
                 </a:solidFill>
               </a:rPr>
-              <a:t>-  Best clustering silhouette: 0.907</a:t>
+              <a:t>-  Best clustering silhouette: 0.762</a:t>
             </a:r>
           </a:p>
         </p:txBody>
@@ -10433,7 +10433,7 @@
                   <a:srgbClr val="FFFFFF"/>
                 </a:solidFill>
               </a:rPr>
-              <a:t>-  Dense embeddings: 500 x 384 dims</a:t>
+              <a:t>-  Dense embeddings: 5,000 x 384 dims</a:t>
             </a:r>
           </a:p>
           <a:p>
@@ -10478,7 +10478,7 @@
                   <a:srgbClr val="FFFFFF"/>
                 </a:solidFill>
               </a:rPr>
-              <a:t>-  State-of-the-art sentence encoding</a:t>
+              <a:t>-  Embedding cache: skip re-encoding</a:t>
             </a:r>
           </a:p>
         </p:txBody>
@@ -11270,7 +11270,7 @@
                   <a:srgbClr val="0F3460"/>
                 </a:solidFill>
               </a:rPr>
-              <a:t>0.059</a:t>
+              <a:t>0.113</a:t>
             </a:r>
           </a:p>
         </p:txBody>
@@ -11349,7 +11349,7 @@
                   <a:srgbClr val="0F3460"/>
                 </a:solidFill>
               </a:rPr>
-              <a:t>4.957</a:t>
+              <a:t>3.603</a:t>
             </a:r>
           </a:p>
         </p:txBody>
@@ -11428,7 +11428,7 @@
                   <a:srgbClr val="0F3460"/>
                 </a:solidFill>
               </a:rPr>
-              <a:t>0.942</a:t>
+              <a:t>0.908</a:t>
             </a:r>
           </a:p>
         </p:txBody>
@@ -11665,7 +11665,7 @@
                   <a:srgbClr val="0F3460"/>
                 </a:solidFill>
               </a:rPr>
-              <a:t>0.907</a:t>
+              <a:t>0.762</a:t>
             </a:r>
           </a:p>
         </p:txBody>
@@ -11744,7 +11744,7 @@
                   <a:srgbClr val="0F3460"/>
                 </a:solidFill>
               </a:rPr>
-              <a:t>0.281</a:t>
+              <a:t>0.618</a:t>
             </a:r>
           </a:p>
         </p:txBody>
@@ -11823,7 +11823,7 @@
                   <a:srgbClr val="0F3460"/>
                 </a:solidFill>
               </a:rPr>
-              <a:t>1.000</a:t>
+              <a:t>0.999</a:t>
             </a:r>
           </a:p>
         </p:txBody>
@@ -12060,7 +12060,7 @@
                   <a:srgbClr val="0F3460"/>
                 </a:solidFill>
               </a:rPr>
-              <a:t>0.055</a:t>
+              <a:t>0.045</a:t>
             </a:r>
           </a:p>
         </p:txBody>
@@ -12139,7 +12139,7 @@
                   <a:srgbClr val="0F3460"/>
                 </a:solidFill>
               </a:rPr>
-              <a:t>5.633</a:t>
+              <a:t>5.061</a:t>
             </a:r>
           </a:p>
         </p:txBody>
@@ -12218,7 +12218,7 @@
                   <a:srgbClr val="0F3460"/>
                 </a:solidFill>
               </a:rPr>
-              <a:t>0.937</a:t>
+              <a:t>0.940</a:t>
             </a:r>
           </a:p>
         </p:txBody>
@@ -12455,7 +12455,7 @@
                   <a:srgbClr val="0F3460"/>
                 </a:solidFill>
               </a:rPr>
-              <a:t>0.046</a:t>
+              <a:t>0.026</a:t>
             </a:r>
           </a:p>
         </p:txBody>
@@ -12534,7 +12534,7 @@
                   <a:srgbClr val="0F3460"/>
                 </a:solidFill>
               </a:rPr>
-              <a:t>6.327</a:t>
+              <a:t>6.010</a:t>
             </a:r>
           </a:p>
         </p:txBody>
@@ -12613,7 +12613,7 @@
                   <a:srgbClr val="0F3460"/>
                 </a:solidFill>
               </a:rPr>
-              <a:t>0.937</a:t>
+              <a:t>0.940</a:t>
             </a:r>
           </a:p>
         </p:txBody>
@@ -12764,7 +12764,7 @@
                   <a:srgbClr val="222222"/>
                 </a:solidFill>
               </a:rPr>
-              <a:t>•  LDA + KMeans achieves the highest Silhouette (0.907) and perfect Stability (1.000) — clean topical separation</a:t>
+              <a:t>•  LDA + KMeans achieves the highest Silhouette (0.762) and near-perfect Stability (0.999) on 5,000 real patents</a:t>
             </a:r>
           </a:p>
           <a:p>
@@ -12779,7 +12779,7 @@
                   <a:srgbClr val="222222"/>
                 </a:solidFill>
               </a:rPr>
-              <a:t>•  SBERT embeddings show lower silhouette scores typical of real-world high-dimensional patent data</a:t>
+              <a:t>•  TF-IDF + KMeans yields the strongest interpretable clusters (low DB = 3.60, k=5 matches CPC sections)</a:t>
             </a:r>
           </a:p>
           <a:p>
@@ -12794,7 +12794,7 @@
                   <a:srgbClr val="222222"/>
                 </a:solidFill>
               </a:rPr>
-              <a:t>•  Hierarchical clustering (Ward linkage) matches K-Means on real data stability</a:t>
+              <a:t>•  SBERT embeddings show lower silhouette typical of real-world dense semantic spaces with overlapping domains</a:t>
             </a:r>
           </a:p>
         </p:txBody>
@@ -14209,7 +14209,7 @@
                   <a:srgbClr val="0F3460"/>
                 </a:solidFill>
               </a:rPr>
-              <a:t>0.303</a:t>
+              <a:t>0.260</a:t>
             </a:r>
           </a:p>
         </p:txBody>
@@ -14288,7 +14288,7 @@
                   <a:srgbClr val="0F3460"/>
                 </a:solidFill>
               </a:rPr>
-              <a:t>0.036</a:t>
+              <a:t>0.006</a:t>
             </a:r>
           </a:p>
         </p:txBody>
@@ -14367,7 +14367,7 @@
                   <a:srgbClr val="0F3460"/>
                 </a:solidFill>
               </a:rPr>
-              <a:t>0.216</a:t>
+              <a:t>0.193</a:t>
             </a:r>
           </a:p>
         </p:txBody>
@@ -14446,7 +14446,7 @@
                   <a:srgbClr val="0F3460"/>
                 </a:solidFill>
               </a:rPr>
-              <a:t>0.188</a:t>
+              <a:t>0.125</a:t>
             </a:r>
           </a:p>
         </p:txBody>
@@ -14525,7 +14525,7 @@
                   <a:srgbClr val="0F3460"/>
                 </a:solidFill>
               </a:rPr>
-              <a:t>0.036</a:t>
+              <a:t>0.025</a:t>
             </a:r>
           </a:p>
         </p:txBody>
@@ -14683,7 +14683,7 @@
                   <a:srgbClr val="0F3460"/>
                 </a:solidFill>
               </a:rPr>
-              <a:t>0.248</a:t>
+              <a:t>0.280</a:t>
             </a:r>
           </a:p>
         </p:txBody>
@@ -14762,7 +14762,7 @@
                   <a:srgbClr val="0F3460"/>
                 </a:solidFill>
               </a:rPr>
-              <a:t>0.000</a:t>
+              <a:t>0.040</a:t>
             </a:r>
           </a:p>
         </p:txBody>
@@ -14841,7 +14841,7 @@
                   <a:srgbClr val="0F3460"/>
                 </a:solidFill>
               </a:rPr>
-              <a:t>0.199</a:t>
+              <a:t>0.239</a:t>
             </a:r>
           </a:p>
         </p:txBody>
@@ -14920,7 +14920,7 @@
                   <a:srgbClr val="0F3460"/>
                 </a:solidFill>
               </a:rPr>
-              <a:t>0.188</a:t>
+              <a:t>0.200</a:t>
             </a:r>
           </a:p>
         </p:txBody>
@@ -14999,7 +14999,7 @@
                   <a:srgbClr val="0F3460"/>
                 </a:solidFill>
               </a:rPr>
-              <a:t>0.034</a:t>
+              <a:t>0.039</a:t>
             </a:r>
           </a:p>
         </p:txBody>
@@ -15157,7 +15157,7 @@
                   <a:srgbClr val="0F3460"/>
                 </a:solidFill>
               </a:rPr>
-              <a:t>0.221</a:t>
+              <a:t>0.266</a:t>
             </a:r>
           </a:p>
         </p:txBody>
@@ -15236,7 +15236,7 @@
                   <a:srgbClr val="0F3460"/>
                 </a:solidFill>
               </a:rPr>
-              <a:t>0.000</a:t>
+              <a:t>0.013</a:t>
             </a:r>
           </a:p>
         </p:txBody>
@@ -15315,7 +15315,7 @@
                   <a:srgbClr val="0F3460"/>
                 </a:solidFill>
               </a:rPr>
-              <a:t>0.179</a:t>
+              <a:t>0.206</a:t>
             </a:r>
           </a:p>
         </p:txBody>
@@ -15394,7 +15394,7 @@
                   <a:srgbClr val="0F3460"/>
                 </a:solidFill>
               </a:rPr>
-              <a:t>0.188</a:t>
+              <a:t>0.100</a:t>
             </a:r>
           </a:p>
         </p:txBody>
@@ -15473,7 +15473,7 @@
                   <a:srgbClr val="0F3460"/>
                 </a:solidFill>
               </a:rPr>
-              <a:t>0.019</a:t>
+              <a:t>0.028</a:t>
             </a:r>
           </a:p>
         </p:txBody>
@@ -15631,7 +15631,7 @@
                   <a:srgbClr val="0F3460"/>
                 </a:solidFill>
               </a:rPr>
-              <a:t>0.257</a:t>
+              <a:t>0.284</a:t>
             </a:r>
           </a:p>
         </p:txBody>
@@ -15710,7 +15710,7 @@
                   <a:srgbClr val="0F3460"/>
                 </a:solidFill>
               </a:rPr>
-              <a:t>0.019</a:t>
+              <a:t>0.034</a:t>
             </a:r>
           </a:p>
         </p:txBody>
@@ -15789,7 +15789,7 @@
                   <a:srgbClr val="0F3460"/>
                 </a:solidFill>
               </a:rPr>
-              <a:t>0.179</a:t>
+              <a:t>0.203</a:t>
             </a:r>
           </a:p>
         </p:txBody>
@@ -15868,7 +15868,7 @@
                   <a:srgbClr val="0F3460"/>
                 </a:solidFill>
               </a:rPr>
-              <a:t>0.000</a:t>
+              <a:t>0.100</a:t>
             </a:r>
           </a:p>
         </p:txBody>
@@ -15947,7 +15947,7 @@
                   <a:srgbClr val="0F3460"/>
                 </a:solidFill>
               </a:rPr>
-              <a:t>0.007</a:t>
+              <a:t>0.033</a:t>
             </a:r>
           </a:p>
         </p:txBody>
@@ -16064,7 +16064,7 @@
                   <a:srgbClr val="222222"/>
                 </a:solidFill>
               </a:rPr>
-              <a:t>•  TF-IDF + KMeans achieves best ROUGE-1 (0.303) and ROUGE-L (0.216)</a:t>
+              <a:t>•  LDA + KMeans wins ROUGE-2 (0.040), ROUGE-L (0.239) and Coverage (0.200) -- best balance overall</a:t>
             </a:r>
           </a:p>
         </p:txBody>

</xml_diff>

<commit_message>
Improve PPTX: aspect-ratio-preserving images + redesigned architecture slide
- Add fit_picture() helper that reads PNG dimensions and centers the
  image inside a bounding box without stretching. Replaces 5 squeezed
  add_picture() calls (all_projections_tsne was 3.92:1 forced into
  2.34:1, lda_topics was 1.33:1 forced into 1.21:1, etc).
- Redesign System Architecture slide: split 7 cramped narrow boxes into
  a clean 2-row layout (3 + 4) with bigger boxes, gold header strips,
  proper right/down arrow shapes, and a caption explaining the flow.
  Top row = data + representations (lighter navy), bottom row =
  analysis + output (deep navy).
</commit_message>
<xml_diff>
--- a/Group22-Project9-SP26-Group-DEMO-Presentation.pptx
+++ b/Group22-Project9-SP26-Group-DEMO-Presentation.pptx
@@ -3741,8 +3741,8 @@
         </p:blipFill>
         <p:spPr>
           <a:xfrm>
-            <a:off x="274320" y="1417320"/>
-            <a:ext cx="5852160" cy="4846320"/>
+            <a:off x="274320" y="1636034"/>
+            <a:ext cx="5852160" cy="4408890"/>
           </a:xfrm>
           <a:prstGeom prst="rect">
             <a:avLst/>
@@ -3765,8 +3765,8 @@
         </p:blipFill>
         <p:spPr>
           <a:xfrm>
-            <a:off x="6309360" y="1417320"/>
-            <a:ext cx="5577840" cy="4846320"/>
+            <a:off x="6567341" y="1463040"/>
+            <a:ext cx="5061876" cy="4754880"/>
           </a:xfrm>
           <a:prstGeom prst="rect">
             <a:avLst/>
@@ -3795,14 +3795,14 @@
           </a:bodyPr>
           <a:lstStyle/>
           <a:p>
-            <a:pPr algn="l"/>
-            <a:r>
-              <a:rPr sz="1100" b="0" i="1">
+            <a:pPr algn="ctr"/>
+            <a:r>
+              <a:rPr sz="1200" b="0" i="1">
                 <a:solidFill>
                   <a:srgbClr val="555555"/>
                 </a:solidFill>
               </a:rPr>
-              <a:t>Top words per topic (left) and document-topic probability heatmap (right)</a:t>
+              <a:t>Top words per topic (left)  ·  Document-topic probability heatmap (right)</a:t>
             </a:r>
           </a:p>
         </p:txBody>
@@ -4072,8 +4072,8 @@
         </p:blipFill>
         <p:spPr>
           <a:xfrm>
-            <a:off x="1371600" y="1417320"/>
-            <a:ext cx="9445752" cy="4389120"/>
+            <a:off x="1812219" y="1463040"/>
+            <a:ext cx="8564512" cy="4206240"/>
           </a:xfrm>
           <a:prstGeom prst="rect">
             <a:avLst/>
@@ -4088,7 +4088,7 @@
         </p:nvSpPr>
         <p:spPr>
           <a:xfrm>
-            <a:off x="457200" y="5943600"/>
+            <a:off x="457200" y="5852160"/>
             <a:ext cx="11247120" cy="777240"/>
           </a:xfrm>
           <a:prstGeom prst="rect">
@@ -5929,7 +5929,7 @@
                   <a:srgbClr val="E9C46A"/>
                 </a:solidFill>
               </a:rPr>
-              <a:t>7-stage end-to-end pipeline</a:t>
+              <a:t>Two-stage pipeline: representation, then analysis</a:t>
             </a:r>
           </a:p>
         </p:txBody>
@@ -6019,14 +6019,14 @@
         </p:nvSpPr>
         <p:spPr>
           <a:xfrm>
-            <a:off x="203454" y="1463040"/>
-            <a:ext cx="1508760" cy="4389120"/>
-          </a:xfrm>
-          <a:prstGeom prst="rect">
-            <a:avLst/>
-          </a:prstGeom>
-          <a:solidFill>
-            <a:srgbClr val="0F3460"/>
+            <a:off x="548640" y="1508760"/>
+            <a:ext cx="3361944" cy="2194560"/>
+          </a:xfrm>
+          <a:prstGeom prst="rect">
+            <a:avLst/>
+          </a:prstGeom>
+          <a:solidFill>
+            <a:srgbClr val="164070"/>
           </a:solidFill>
           <a:ln>
             <a:noFill/>
@@ -6062,8 +6062,8 @@
         </p:nvSpPr>
         <p:spPr>
           <a:xfrm>
-            <a:off x="203454" y="1463040"/>
-            <a:ext cx="1508760" cy="502920"/>
+            <a:off x="548640" y="1508760"/>
+            <a:ext cx="3361944" cy="457200"/>
           </a:xfrm>
           <a:prstGeom prst="rect">
             <a:avLst/>
@@ -6105,8 +6105,8 @@
         </p:nvSpPr>
         <p:spPr>
           <a:xfrm>
-            <a:off x="249174" y="1481328"/>
-            <a:ext cx="1417319" cy="457200"/>
+            <a:off x="621792" y="1572768"/>
+            <a:ext cx="3215640" cy="365760"/>
           </a:xfrm>
           <a:prstGeom prst="rect">
             <a:avLst/>
@@ -6121,9 +6121,9 @@
           <a:p>
             <a:pPr algn="ctr"/>
             <a:r>
-              <a:rPr sz="1100" b="1" i="0">
-                <a:solidFill>
-                  <a:srgbClr val="0F3460"/>
+              <a:rPr sz="1300" b="1" i="0">
+                <a:solidFill>
+                  <a:srgbClr val="0A2240"/>
                 </a:solidFill>
               </a:rPr>
               <a:t>1. Ingestion</a:t>
@@ -6139,8 +6139,8 @@
         </p:nvSpPr>
         <p:spPr>
           <a:xfrm>
-            <a:off x="276606" y="2057400"/>
-            <a:ext cx="1362456" cy="3474720"/>
+            <a:off x="685800" y="2075688"/>
+            <a:ext cx="3087624" cy="1554480"/>
           </a:xfrm>
           <a:prstGeom prst="rect">
             <a:avLst/>
@@ -6155,64 +6155,31 @@
           <a:p>
             <a:pPr algn="ctr"/>
             <a:r>
-              <a:rPr sz="1000" b="0" i="0">
+              <a:rPr sz="1100" b="0" i="0">
                 <a:solidFill>
                   <a:srgbClr val="FFFFFF"/>
                 </a:solidFill>
               </a:rPr>
               <a:t>Real USPTO patents
 HuggingFace big_patent
-5,000 patents / 5 domains</a:t>
-            </a:r>
-          </a:p>
-        </p:txBody>
-      </p:sp>
-      <p:sp>
-        <p:nvSpPr>
-          <p:cNvPr id="12" name="TextBox 11"/>
-          <p:cNvSpPr txBox="1"/>
-          <p:nvPr/>
-        </p:nvSpPr>
-        <p:spPr>
-          <a:xfrm>
-            <a:off x="1722501" y="3520440"/>
-            <a:ext cx="274320" cy="365760"/>
-          </a:xfrm>
-          <a:prstGeom prst="rect">
-            <a:avLst/>
-          </a:prstGeom>
-          <a:noFill/>
-        </p:spPr>
-        <p:txBody>
-          <a:bodyPr wrap="square">
-            <a:spAutoFit/>
-          </a:bodyPr>
-          <a:lstStyle/>
-          <a:p>
-            <a:pPr algn="ctr"/>
-            <a:r>
-              <a:rPr sz="1400" b="1" i="0">
-                <a:solidFill>
-                  <a:srgbClr val="0F3460"/>
-                </a:solidFill>
-              </a:rPr>
-              <a:t>-&gt;</a:t>
-            </a:r>
-          </a:p>
-        </p:txBody>
-      </p:sp>
-      <p:sp>
-        <p:nvSpPr>
-          <p:cNvPr id="13" name="Rectangle 12"/>
+5,000 docs across
+5 CPC domains</a:t>
+            </a:r>
+          </a:p>
+        </p:txBody>
+      </p:sp>
+      <p:sp>
+        <p:nvSpPr>
+          <p:cNvPr id="12" name="Can 11"/>
           <p:cNvSpPr/>
           <p:nvPr/>
         </p:nvSpPr>
         <p:spPr>
           <a:xfrm>
-            <a:off x="1915668" y="1463040"/>
-            <a:ext cx="1508760" cy="4389120"/>
-          </a:xfrm>
-          <a:prstGeom prst="rect">
+            <a:off x="3956304" y="2441447"/>
+            <a:ext cx="411480" cy="320040"/>
+          </a:xfrm>
+          <a:prstGeom prst="can">
             <a:avLst/>
           </a:prstGeom>
           <a:solidFill>
@@ -6246,20 +6213,20 @@
       </p:sp>
       <p:sp>
         <p:nvSpPr>
-          <p:cNvPr id="14" name="Rectangle 13"/>
+          <p:cNvPr id="13" name="Rectangle 12"/>
           <p:cNvSpPr/>
           <p:nvPr/>
         </p:nvSpPr>
         <p:spPr>
           <a:xfrm>
-            <a:off x="1915668" y="1463040"/>
-            <a:ext cx="1508760" cy="502920"/>
-          </a:xfrm>
-          <a:prstGeom prst="rect">
-            <a:avLst/>
-          </a:prstGeom>
-          <a:solidFill>
-            <a:srgbClr val="E9C46A"/>
+            <a:off x="4413504" y="1508760"/>
+            <a:ext cx="3361944" cy="2194560"/>
+          </a:xfrm>
+          <a:prstGeom prst="rect">
+            <a:avLst/>
+          </a:prstGeom>
+          <a:solidFill>
+            <a:srgbClr val="164070"/>
           </a:solidFill>
           <a:ln>
             <a:noFill/>
@@ -6289,124 +6256,20 @@
       </p:sp>
       <p:sp>
         <p:nvSpPr>
-          <p:cNvPr id="15" name="TextBox 14"/>
-          <p:cNvSpPr txBox="1"/>
-          <p:nvPr/>
-        </p:nvSpPr>
-        <p:spPr>
-          <a:xfrm>
-            <a:off x="1961388" y="1481328"/>
-            <a:ext cx="1417319" cy="457200"/>
-          </a:xfrm>
-          <a:prstGeom prst="rect">
-            <a:avLst/>
-          </a:prstGeom>
-          <a:noFill/>
-        </p:spPr>
-        <p:txBody>
-          <a:bodyPr wrap="square">
-            <a:spAutoFit/>
-          </a:bodyPr>
-          <a:lstStyle/>
-          <a:p>
-            <a:pPr algn="ctr"/>
-            <a:r>
-              <a:rPr sz="1100" b="1" i="0">
-                <a:solidFill>
-                  <a:srgbClr val="0F3460"/>
-                </a:solidFill>
-              </a:rPr>
-              <a:t>2. Preprocessing</a:t>
-            </a:r>
-          </a:p>
-        </p:txBody>
-      </p:sp>
-      <p:sp>
-        <p:nvSpPr>
-          <p:cNvPr id="16" name="TextBox 15"/>
-          <p:cNvSpPr txBox="1"/>
-          <p:nvPr/>
-        </p:nvSpPr>
-        <p:spPr>
-          <a:xfrm>
-            <a:off x="1988820" y="2057400"/>
-            <a:ext cx="1362456" cy="3474720"/>
-          </a:xfrm>
-          <a:prstGeom prst="rect">
-            <a:avLst/>
-          </a:prstGeom>
-          <a:noFill/>
-        </p:spPr>
-        <p:txBody>
-          <a:bodyPr wrap="square">
-            <a:spAutoFit/>
-          </a:bodyPr>
-          <a:lstStyle/>
-          <a:p>
-            <a:pPr algn="ctr"/>
-            <a:r>
-              <a:rPr sz="1000" b="0" i="0">
-                <a:solidFill>
-                  <a:srgbClr val="FFFFFF"/>
-                </a:solidFill>
-              </a:rPr>
-              <a:t>Lowercasing, punct strip
-Stopword removal
-Lemmatisation</a:t>
-            </a:r>
-          </a:p>
-        </p:txBody>
-      </p:sp>
-      <p:sp>
-        <p:nvSpPr>
-          <p:cNvPr id="17" name="TextBox 16"/>
-          <p:cNvSpPr txBox="1"/>
-          <p:nvPr/>
-        </p:nvSpPr>
-        <p:spPr>
-          <a:xfrm>
-            <a:off x="3434715" y="3520440"/>
-            <a:ext cx="274320" cy="365760"/>
-          </a:xfrm>
-          <a:prstGeom prst="rect">
-            <a:avLst/>
-          </a:prstGeom>
-          <a:noFill/>
-        </p:spPr>
-        <p:txBody>
-          <a:bodyPr wrap="square">
-            <a:spAutoFit/>
-          </a:bodyPr>
-          <a:lstStyle/>
-          <a:p>
-            <a:pPr algn="ctr"/>
-            <a:r>
-              <a:rPr sz="1400" b="1" i="0">
-                <a:solidFill>
-                  <a:srgbClr val="0F3460"/>
-                </a:solidFill>
-              </a:rPr>
-              <a:t>-&gt;</a:t>
-            </a:r>
-          </a:p>
-        </p:txBody>
-      </p:sp>
-      <p:sp>
-        <p:nvSpPr>
-          <p:cNvPr id="18" name="Rectangle 17"/>
+          <p:cNvPr id="14" name="Rectangle 13"/>
           <p:cNvSpPr/>
           <p:nvPr/>
         </p:nvSpPr>
         <p:spPr>
           <a:xfrm>
-            <a:off x="3627882" y="1463040"/>
-            <a:ext cx="1508760" cy="4389120"/>
-          </a:xfrm>
-          <a:prstGeom prst="rect">
-            <a:avLst/>
-          </a:prstGeom>
-          <a:solidFill>
-            <a:srgbClr val="0F3460"/>
+            <a:off x="4413504" y="1508760"/>
+            <a:ext cx="3361944" cy="457200"/>
+          </a:xfrm>
+          <a:prstGeom prst="rect">
+            <a:avLst/>
+          </a:prstGeom>
+          <a:solidFill>
+            <a:srgbClr val="E9C46A"/>
           </a:solidFill>
           <a:ln>
             <a:noFill/>
@@ -6436,20 +6299,91 @@
       </p:sp>
       <p:sp>
         <p:nvSpPr>
-          <p:cNvPr id="19" name="Rectangle 18"/>
+          <p:cNvPr id="15" name="TextBox 14"/>
+          <p:cNvSpPr txBox="1"/>
+          <p:nvPr/>
+        </p:nvSpPr>
+        <p:spPr>
+          <a:xfrm>
+            <a:off x="4486656" y="1572768"/>
+            <a:ext cx="3215640" cy="365760"/>
+          </a:xfrm>
+          <a:prstGeom prst="rect">
+            <a:avLst/>
+          </a:prstGeom>
+          <a:noFill/>
+        </p:spPr>
+        <p:txBody>
+          <a:bodyPr wrap="square">
+            <a:spAutoFit/>
+          </a:bodyPr>
+          <a:lstStyle/>
+          <a:p>
+            <a:pPr algn="ctr"/>
+            <a:r>
+              <a:rPr sz="1300" b="1" i="0">
+                <a:solidFill>
+                  <a:srgbClr val="0A2240"/>
+                </a:solidFill>
+              </a:rPr>
+              <a:t>2. Preprocessing</a:t>
+            </a:r>
+          </a:p>
+        </p:txBody>
+      </p:sp>
+      <p:sp>
+        <p:nvSpPr>
+          <p:cNvPr id="16" name="TextBox 15"/>
+          <p:cNvSpPr txBox="1"/>
+          <p:nvPr/>
+        </p:nvSpPr>
+        <p:spPr>
+          <a:xfrm>
+            <a:off x="4550664" y="2075688"/>
+            <a:ext cx="3087624" cy="1554480"/>
+          </a:xfrm>
+          <a:prstGeom prst="rect">
+            <a:avLst/>
+          </a:prstGeom>
+          <a:noFill/>
+        </p:spPr>
+        <p:txBody>
+          <a:bodyPr wrap="square">
+            <a:spAutoFit/>
+          </a:bodyPr>
+          <a:lstStyle/>
+          <a:p>
+            <a:pPr algn="ctr"/>
+            <a:r>
+              <a:rPr sz="1100" b="0" i="0">
+                <a:solidFill>
+                  <a:srgbClr val="FFFFFF"/>
+                </a:solidFill>
+              </a:rPr>
+              <a:t>Lowercase + punct strip
+NLTK stopwords removed
+Lemmatisation
+(WordNet)</a:t>
+            </a:r>
+          </a:p>
+        </p:txBody>
+      </p:sp>
+      <p:sp>
+        <p:nvSpPr>
+          <p:cNvPr id="17" name="Can 16"/>
           <p:cNvSpPr/>
           <p:nvPr/>
         </p:nvSpPr>
         <p:spPr>
           <a:xfrm>
-            <a:off x="3627882" y="1463040"/>
-            <a:ext cx="1508760" cy="502920"/>
-          </a:xfrm>
-          <a:prstGeom prst="rect">
-            <a:avLst/>
-          </a:prstGeom>
-          <a:solidFill>
-            <a:srgbClr val="E9C46A"/>
+            <a:off x="7821168" y="2441447"/>
+            <a:ext cx="411480" cy="320040"/>
+          </a:xfrm>
+          <a:prstGeom prst="can">
+            <a:avLst/>
+          </a:prstGeom>
+          <a:solidFill>
+            <a:srgbClr val="0F3460"/>
           </a:solidFill>
           <a:ln>
             <a:noFill/>
@@ -6479,124 +6413,20 @@
       </p:sp>
       <p:sp>
         <p:nvSpPr>
-          <p:cNvPr id="20" name="TextBox 19"/>
-          <p:cNvSpPr txBox="1"/>
-          <p:nvPr/>
-        </p:nvSpPr>
-        <p:spPr>
-          <a:xfrm>
-            <a:off x="3673602" y="1481328"/>
-            <a:ext cx="1417319" cy="457200"/>
-          </a:xfrm>
-          <a:prstGeom prst="rect">
-            <a:avLst/>
-          </a:prstGeom>
-          <a:noFill/>
-        </p:spPr>
-        <p:txBody>
-          <a:bodyPr wrap="square">
-            <a:spAutoFit/>
-          </a:bodyPr>
-          <a:lstStyle/>
-          <a:p>
-            <a:pPr algn="ctr"/>
-            <a:r>
-              <a:rPr sz="1100" b="1" i="0">
-                <a:solidFill>
-                  <a:srgbClr val="0F3460"/>
-                </a:solidFill>
-              </a:rPr>
-              <a:t>3. Feature Eng.</a:t>
-            </a:r>
-          </a:p>
-        </p:txBody>
-      </p:sp>
-      <p:sp>
-        <p:nvSpPr>
-          <p:cNvPr id="21" name="TextBox 20"/>
-          <p:cNvSpPr txBox="1"/>
-          <p:nvPr/>
-        </p:nvSpPr>
-        <p:spPr>
-          <a:xfrm>
-            <a:off x="3701034" y="2057400"/>
-            <a:ext cx="1362456" cy="3474720"/>
-          </a:xfrm>
-          <a:prstGeom prst="rect">
-            <a:avLst/>
-          </a:prstGeom>
-          <a:noFill/>
-        </p:spPr>
-        <p:txBody>
-          <a:bodyPr wrap="square">
-            <a:spAutoFit/>
-          </a:bodyPr>
-          <a:lstStyle/>
-          <a:p>
-            <a:pPr algn="ctr"/>
-            <a:r>
-              <a:rPr sz="1000" b="0" i="0">
-                <a:solidFill>
-                  <a:srgbClr val="FFFFFF"/>
-                </a:solidFill>
-              </a:rPr>
-              <a:t>TF-IDF + LSA
-LDA topics
-Sentence-BERT</a:t>
-            </a:r>
-          </a:p>
-        </p:txBody>
-      </p:sp>
-      <p:sp>
-        <p:nvSpPr>
-          <p:cNvPr id="22" name="TextBox 21"/>
-          <p:cNvSpPr txBox="1"/>
-          <p:nvPr/>
-        </p:nvSpPr>
-        <p:spPr>
-          <a:xfrm>
-            <a:off x="5146929" y="3520440"/>
-            <a:ext cx="274320" cy="365760"/>
-          </a:xfrm>
-          <a:prstGeom prst="rect">
-            <a:avLst/>
-          </a:prstGeom>
-          <a:noFill/>
-        </p:spPr>
-        <p:txBody>
-          <a:bodyPr wrap="square">
-            <a:spAutoFit/>
-          </a:bodyPr>
-          <a:lstStyle/>
-          <a:p>
-            <a:pPr algn="ctr"/>
-            <a:r>
-              <a:rPr sz="1400" b="1" i="0">
-                <a:solidFill>
-                  <a:srgbClr val="0F3460"/>
-                </a:solidFill>
-              </a:rPr>
-              <a:t>-&gt;</a:t>
-            </a:r>
-          </a:p>
-        </p:txBody>
-      </p:sp>
-      <p:sp>
-        <p:nvSpPr>
-          <p:cNvPr id="23" name="Rectangle 22"/>
+          <p:cNvPr id="18" name="Rectangle 17"/>
           <p:cNvSpPr/>
           <p:nvPr/>
         </p:nvSpPr>
         <p:spPr>
           <a:xfrm>
-            <a:off x="5340096" y="1463040"/>
-            <a:ext cx="1508760" cy="4389120"/>
-          </a:xfrm>
-          <a:prstGeom prst="rect">
-            <a:avLst/>
-          </a:prstGeom>
-          <a:solidFill>
-            <a:srgbClr val="0F3460"/>
+            <a:off x="8278368" y="1508760"/>
+            <a:ext cx="3361944" cy="2194560"/>
+          </a:xfrm>
+          <a:prstGeom prst="rect">
+            <a:avLst/>
+          </a:prstGeom>
+          <a:solidFill>
+            <a:srgbClr val="164070"/>
           </a:solidFill>
           <a:ln>
             <a:noFill/>
@@ -6626,14 +6456,14 @@
       </p:sp>
       <p:sp>
         <p:nvSpPr>
-          <p:cNvPr id="24" name="Rectangle 23"/>
+          <p:cNvPr id="19" name="Rectangle 18"/>
           <p:cNvSpPr/>
           <p:nvPr/>
         </p:nvSpPr>
         <p:spPr>
           <a:xfrm>
-            <a:off x="5340096" y="1463040"/>
-            <a:ext cx="1508760" cy="502920"/>
+            <a:off x="8278368" y="1508760"/>
+            <a:ext cx="3361944" cy="457200"/>
           </a:xfrm>
           <a:prstGeom prst="rect">
             <a:avLst/>
@@ -6669,14 +6499,14 @@
       </p:sp>
       <p:sp>
         <p:nvSpPr>
-          <p:cNvPr id="25" name="TextBox 24"/>
+          <p:cNvPr id="20" name="TextBox 19"/>
           <p:cNvSpPr txBox="1"/>
           <p:nvPr/>
         </p:nvSpPr>
         <p:spPr>
           <a:xfrm>
-            <a:off x="5385816" y="1481328"/>
-            <a:ext cx="1417319" cy="457200"/>
+            <a:off x="8351520" y="1572768"/>
+            <a:ext cx="3215640" cy="365760"/>
           </a:xfrm>
           <a:prstGeom prst="rect">
             <a:avLst/>
@@ -6691,26 +6521,26 @@
           <a:p>
             <a:pPr algn="ctr"/>
             <a:r>
-              <a:rPr sz="1100" b="1" i="0">
-                <a:solidFill>
-                  <a:srgbClr val="0F3460"/>
-                </a:solidFill>
-              </a:rPr>
-              <a:t>4. Clustering</a:t>
-            </a:r>
-          </a:p>
-        </p:txBody>
-      </p:sp>
-      <p:sp>
-        <p:nvSpPr>
-          <p:cNvPr id="26" name="TextBox 25"/>
+              <a:rPr sz="1300" b="1" i="0">
+                <a:solidFill>
+                  <a:srgbClr val="0A2240"/>
+                </a:solidFill>
+              </a:rPr>
+              <a:t>3. Feature Eng.</a:t>
+            </a:r>
+          </a:p>
+        </p:txBody>
+      </p:sp>
+      <p:sp>
+        <p:nvSpPr>
+          <p:cNvPr id="21" name="TextBox 20"/>
           <p:cNvSpPr txBox="1"/>
           <p:nvPr/>
         </p:nvSpPr>
         <p:spPr>
           <a:xfrm>
-            <a:off x="5413248" y="2057400"/>
-            <a:ext cx="1362456" cy="3474720"/>
+            <a:off x="8415528" y="2075688"/>
+            <a:ext cx="3087624" cy="1554480"/>
           </a:xfrm>
           <a:prstGeom prst="rect">
             <a:avLst/>
@@ -6725,64 +6555,31 @@
           <a:p>
             <a:pPr algn="ctr"/>
             <a:r>
-              <a:rPr sz="1000" b="0" i="0">
+              <a:rPr sz="1100" b="0" i="0">
                 <a:solidFill>
                   <a:srgbClr val="FFFFFF"/>
                 </a:solidFill>
               </a:rPr>
-              <a:t>K-Means++
-Hierarchical (Ward)
-Optimal-k search</a:t>
-            </a:r>
-          </a:p>
-        </p:txBody>
-      </p:sp>
-      <p:sp>
-        <p:nvSpPr>
-          <p:cNvPr id="27" name="TextBox 26"/>
-          <p:cNvSpPr txBox="1"/>
-          <p:nvPr/>
-        </p:nvSpPr>
-        <p:spPr>
-          <a:xfrm>
-            <a:off x="6859143" y="3520440"/>
-            <a:ext cx="274320" cy="365760"/>
-          </a:xfrm>
-          <a:prstGeom prst="rect">
-            <a:avLst/>
-          </a:prstGeom>
-          <a:noFill/>
-        </p:spPr>
-        <p:txBody>
-          <a:bodyPr wrap="square">
-            <a:spAutoFit/>
-          </a:bodyPr>
-          <a:lstStyle/>
-          <a:p>
-            <a:pPr algn="ctr"/>
-            <a:r>
-              <a:rPr sz="1400" b="1" i="0">
-                <a:solidFill>
-                  <a:srgbClr val="0F3460"/>
-                </a:solidFill>
-              </a:rPr>
-              <a:t>-&gt;</a:t>
-            </a:r>
-          </a:p>
-        </p:txBody>
-      </p:sp>
-      <p:sp>
-        <p:nvSpPr>
-          <p:cNvPr id="28" name="Rectangle 27"/>
+              <a:t>TF-IDF + LSA  (50d)
+LDA topics  (3d)
+Sentence-BERT  (384d)
+all-MiniLM-L6-v2</a:t>
+            </a:r>
+          </a:p>
+        </p:txBody>
+      </p:sp>
+      <p:sp>
+        <p:nvSpPr>
+          <p:cNvPr id="22" name="Cube 21"/>
           <p:cNvSpPr/>
           <p:nvPr/>
         </p:nvSpPr>
         <p:spPr>
           <a:xfrm>
-            <a:off x="7052310" y="1463040"/>
-            <a:ext cx="1508760" cy="4389120"/>
-          </a:xfrm>
-          <a:prstGeom prst="rect">
+            <a:off x="5929884" y="3749039"/>
+            <a:ext cx="320040" cy="320040"/>
+          </a:xfrm>
+          <a:prstGeom prst="cube">
             <a:avLst/>
           </a:prstGeom>
           <a:solidFill>
@@ -6816,20 +6613,20 @@
       </p:sp>
       <p:sp>
         <p:nvSpPr>
-          <p:cNvPr id="29" name="Rectangle 28"/>
+          <p:cNvPr id="23" name="Rectangle 22"/>
           <p:cNvSpPr/>
           <p:nvPr/>
         </p:nvSpPr>
         <p:spPr>
           <a:xfrm>
-            <a:off x="7052310" y="1463040"/>
-            <a:ext cx="1508760" cy="502920"/>
-          </a:xfrm>
-          <a:prstGeom prst="rect">
-            <a:avLst/>
-          </a:prstGeom>
-          <a:solidFill>
-            <a:srgbClr val="E9C46A"/>
+            <a:off x="548640" y="4114800"/>
+            <a:ext cx="2498598" cy="2194560"/>
+          </a:xfrm>
+          <a:prstGeom prst="rect">
+            <a:avLst/>
+          </a:prstGeom>
+          <a:solidFill>
+            <a:srgbClr val="0A2240"/>
           </a:solidFill>
           <a:ln>
             <a:noFill/>
@@ -6859,124 +6656,20 @@
       </p:sp>
       <p:sp>
         <p:nvSpPr>
-          <p:cNvPr id="30" name="TextBox 29"/>
-          <p:cNvSpPr txBox="1"/>
-          <p:nvPr/>
-        </p:nvSpPr>
-        <p:spPr>
-          <a:xfrm>
-            <a:off x="7098030" y="1481328"/>
-            <a:ext cx="1417319" cy="457200"/>
-          </a:xfrm>
-          <a:prstGeom prst="rect">
-            <a:avLst/>
-          </a:prstGeom>
-          <a:noFill/>
-        </p:spPr>
-        <p:txBody>
-          <a:bodyPr wrap="square">
-            <a:spAutoFit/>
-          </a:bodyPr>
-          <a:lstStyle/>
-          <a:p>
-            <a:pPr algn="ctr"/>
-            <a:r>
-              <a:rPr sz="1100" b="1" i="0">
-                <a:solidFill>
-                  <a:srgbClr val="0F3460"/>
-                </a:solidFill>
-              </a:rPr>
-              <a:t>5. Summarization</a:t>
-            </a:r>
-          </a:p>
-        </p:txBody>
-      </p:sp>
-      <p:sp>
-        <p:nvSpPr>
-          <p:cNvPr id="31" name="TextBox 30"/>
-          <p:cNvSpPr txBox="1"/>
-          <p:nvPr/>
-        </p:nvSpPr>
-        <p:spPr>
-          <a:xfrm>
-            <a:off x="7125462" y="2057400"/>
-            <a:ext cx="1362456" cy="3474720"/>
-          </a:xfrm>
-          <a:prstGeom prst="rect">
-            <a:avLst/>
-          </a:prstGeom>
-          <a:noFill/>
-        </p:spPr>
-        <p:txBody>
-          <a:bodyPr wrap="square">
-            <a:spAutoFit/>
-          </a:bodyPr>
-          <a:lstStyle/>
-          <a:p>
-            <a:pPr algn="ctr"/>
-            <a:r>
-              <a:rPr sz="1000" b="0" i="0">
-                <a:solidFill>
-                  <a:srgbClr val="FFFFFF"/>
-                </a:solidFill>
-              </a:rPr>
-              <a:t>TF-IDF sentence rank
-Keyword extraction
-ROUGE evaluation</a:t>
-            </a:r>
-          </a:p>
-        </p:txBody>
-      </p:sp>
-      <p:sp>
-        <p:nvSpPr>
-          <p:cNvPr id="32" name="TextBox 31"/>
-          <p:cNvSpPr txBox="1"/>
-          <p:nvPr/>
-        </p:nvSpPr>
-        <p:spPr>
-          <a:xfrm>
-            <a:off x="8571357" y="3520440"/>
-            <a:ext cx="274320" cy="365760"/>
-          </a:xfrm>
-          <a:prstGeom prst="rect">
-            <a:avLst/>
-          </a:prstGeom>
-          <a:noFill/>
-        </p:spPr>
-        <p:txBody>
-          <a:bodyPr wrap="square">
-            <a:spAutoFit/>
-          </a:bodyPr>
-          <a:lstStyle/>
-          <a:p>
-            <a:pPr algn="ctr"/>
-            <a:r>
-              <a:rPr sz="1400" b="1" i="0">
-                <a:solidFill>
-                  <a:srgbClr val="0F3460"/>
-                </a:solidFill>
-              </a:rPr>
-              <a:t>-&gt;</a:t>
-            </a:r>
-          </a:p>
-        </p:txBody>
-      </p:sp>
-      <p:sp>
-        <p:nvSpPr>
-          <p:cNvPr id="33" name="Rectangle 32"/>
+          <p:cNvPr id="24" name="Rectangle 23"/>
           <p:cNvSpPr/>
           <p:nvPr/>
         </p:nvSpPr>
         <p:spPr>
           <a:xfrm>
-            <a:off x="8764524" y="1463040"/>
-            <a:ext cx="1508760" cy="4389120"/>
-          </a:xfrm>
-          <a:prstGeom prst="rect">
-            <a:avLst/>
-          </a:prstGeom>
-          <a:solidFill>
-            <a:srgbClr val="0F3460"/>
+            <a:off x="548640" y="4114800"/>
+            <a:ext cx="2498598" cy="457200"/>
+          </a:xfrm>
+          <a:prstGeom prst="rect">
+            <a:avLst/>
+          </a:prstGeom>
+          <a:solidFill>
+            <a:srgbClr val="E9C46A"/>
           </a:solidFill>
           <a:ln>
             <a:noFill/>
@@ -7006,20 +6699,91 @@
       </p:sp>
       <p:sp>
         <p:nvSpPr>
-          <p:cNvPr id="34" name="Rectangle 33"/>
+          <p:cNvPr id="25" name="TextBox 24"/>
+          <p:cNvSpPr txBox="1"/>
+          <p:nvPr/>
+        </p:nvSpPr>
+        <p:spPr>
+          <a:xfrm>
+            <a:off x="621792" y="4178808"/>
+            <a:ext cx="2352294" cy="365760"/>
+          </a:xfrm>
+          <a:prstGeom prst="rect">
+            <a:avLst/>
+          </a:prstGeom>
+          <a:noFill/>
+        </p:spPr>
+        <p:txBody>
+          <a:bodyPr wrap="square">
+            <a:spAutoFit/>
+          </a:bodyPr>
+          <a:lstStyle/>
+          <a:p>
+            <a:pPr algn="ctr"/>
+            <a:r>
+              <a:rPr sz="1300" b="1" i="0">
+                <a:solidFill>
+                  <a:srgbClr val="0A2240"/>
+                </a:solidFill>
+              </a:rPr>
+              <a:t>4. Clustering</a:t>
+            </a:r>
+          </a:p>
+        </p:txBody>
+      </p:sp>
+      <p:sp>
+        <p:nvSpPr>
+          <p:cNvPr id="26" name="TextBox 25"/>
+          <p:cNvSpPr txBox="1"/>
+          <p:nvPr/>
+        </p:nvSpPr>
+        <p:spPr>
+          <a:xfrm>
+            <a:off x="685800" y="4681728"/>
+            <a:ext cx="2224278" cy="1554480"/>
+          </a:xfrm>
+          <a:prstGeom prst="rect">
+            <a:avLst/>
+          </a:prstGeom>
+          <a:noFill/>
+        </p:spPr>
+        <p:txBody>
+          <a:bodyPr wrap="square">
+            <a:spAutoFit/>
+          </a:bodyPr>
+          <a:lstStyle/>
+          <a:p>
+            <a:pPr algn="ctr"/>
+            <a:r>
+              <a:rPr sz="1100" b="0" i="0">
+                <a:solidFill>
+                  <a:srgbClr val="FFFFFF"/>
+                </a:solidFill>
+              </a:rPr>
+              <a:t>K-Means++ on 3 reps
+Hierarchical Ward
+on SBERT
++ optimal-k search</a:t>
+            </a:r>
+          </a:p>
+        </p:txBody>
+      </p:sp>
+      <p:sp>
+        <p:nvSpPr>
+          <p:cNvPr id="27" name="Can 26"/>
           <p:cNvSpPr/>
           <p:nvPr/>
         </p:nvSpPr>
         <p:spPr>
           <a:xfrm>
-            <a:off x="8764524" y="1463040"/>
-            <a:ext cx="1508760" cy="502920"/>
-          </a:xfrm>
-          <a:prstGeom prst="rect">
-            <a:avLst/>
-          </a:prstGeom>
-          <a:solidFill>
-            <a:srgbClr val="E9C46A"/>
+            <a:off x="3024378" y="5047488"/>
+            <a:ext cx="411480" cy="320040"/>
+          </a:xfrm>
+          <a:prstGeom prst="can">
+            <a:avLst/>
+          </a:prstGeom>
+          <a:solidFill>
+            <a:srgbClr val="0F3460"/>
           </a:solidFill>
           <a:ln>
             <a:noFill/>
@@ -7049,124 +6813,20 @@
       </p:sp>
       <p:sp>
         <p:nvSpPr>
-          <p:cNvPr id="35" name="TextBox 34"/>
-          <p:cNvSpPr txBox="1"/>
-          <p:nvPr/>
-        </p:nvSpPr>
-        <p:spPr>
-          <a:xfrm>
-            <a:off x="8810244" y="1481328"/>
-            <a:ext cx="1417319" cy="457200"/>
-          </a:xfrm>
-          <a:prstGeom prst="rect">
-            <a:avLst/>
-          </a:prstGeom>
-          <a:noFill/>
-        </p:spPr>
-        <p:txBody>
-          <a:bodyPr wrap="square">
-            <a:spAutoFit/>
-          </a:bodyPr>
-          <a:lstStyle/>
-          <a:p>
-            <a:pPr algn="ctr"/>
-            <a:r>
-              <a:rPr sz="1100" b="1" i="0">
-                <a:solidFill>
-                  <a:srgbClr val="0F3460"/>
-                </a:solidFill>
-              </a:rPr>
-              <a:t>6. Visualization</a:t>
-            </a:r>
-          </a:p>
-        </p:txBody>
-      </p:sp>
-      <p:sp>
-        <p:nvSpPr>
-          <p:cNvPr id="36" name="TextBox 35"/>
-          <p:cNvSpPr txBox="1"/>
-          <p:nvPr/>
-        </p:nvSpPr>
-        <p:spPr>
-          <a:xfrm>
-            <a:off x="8837676" y="2057400"/>
-            <a:ext cx="1362456" cy="3474720"/>
-          </a:xfrm>
-          <a:prstGeom prst="rect">
-            <a:avLst/>
-          </a:prstGeom>
-          <a:noFill/>
-        </p:spPr>
-        <p:txBody>
-          <a:bodyPr wrap="square">
-            <a:spAutoFit/>
-          </a:bodyPr>
-          <a:lstStyle/>
-          <a:p>
-            <a:pPr algn="ctr"/>
-            <a:r>
-              <a:rPr sz="1000" b="0" i="0">
-                <a:solidFill>
-                  <a:srgbClr val="FFFFFF"/>
-                </a:solidFill>
-              </a:rPr>
-              <a:t>t-SNE / PCA 2D
-Metrics bar chart
-Topic heatmap</a:t>
-            </a:r>
-          </a:p>
-        </p:txBody>
-      </p:sp>
-      <p:sp>
-        <p:nvSpPr>
-          <p:cNvPr id="37" name="TextBox 36"/>
-          <p:cNvSpPr txBox="1"/>
-          <p:nvPr/>
-        </p:nvSpPr>
-        <p:spPr>
-          <a:xfrm>
-            <a:off x="10283571" y="3520440"/>
-            <a:ext cx="274320" cy="365760"/>
-          </a:xfrm>
-          <a:prstGeom prst="rect">
-            <a:avLst/>
-          </a:prstGeom>
-          <a:noFill/>
-        </p:spPr>
-        <p:txBody>
-          <a:bodyPr wrap="square">
-            <a:spAutoFit/>
-          </a:bodyPr>
-          <a:lstStyle/>
-          <a:p>
-            <a:pPr algn="ctr"/>
-            <a:r>
-              <a:rPr sz="1400" b="1" i="0">
-                <a:solidFill>
-                  <a:srgbClr val="0F3460"/>
-                </a:solidFill>
-              </a:rPr>
-              <a:t>-&gt;</a:t>
-            </a:r>
-          </a:p>
-        </p:txBody>
-      </p:sp>
-      <p:sp>
-        <p:nvSpPr>
-          <p:cNvPr id="38" name="Rectangle 37"/>
+          <p:cNvPr id="28" name="Rectangle 27"/>
           <p:cNvSpPr/>
           <p:nvPr/>
         </p:nvSpPr>
         <p:spPr>
           <a:xfrm>
-            <a:off x="10476738" y="1463040"/>
-            <a:ext cx="1508760" cy="4389120"/>
-          </a:xfrm>
-          <a:prstGeom prst="rect">
-            <a:avLst/>
-          </a:prstGeom>
-          <a:solidFill>
-            <a:srgbClr val="0F3460"/>
+            <a:off x="3412998" y="4114800"/>
+            <a:ext cx="2498598" cy="2194560"/>
+          </a:xfrm>
+          <a:prstGeom prst="rect">
+            <a:avLst/>
+          </a:prstGeom>
+          <a:solidFill>
+            <a:srgbClr val="0A2240"/>
           </a:solidFill>
           <a:ln>
             <a:noFill/>
@@ -7196,14 +6856,14 @@
       </p:sp>
       <p:sp>
         <p:nvSpPr>
-          <p:cNvPr id="39" name="Rectangle 38"/>
+          <p:cNvPr id="29" name="Rectangle 28"/>
           <p:cNvSpPr/>
           <p:nvPr/>
         </p:nvSpPr>
         <p:spPr>
           <a:xfrm>
-            <a:off x="10476738" y="1463040"/>
-            <a:ext cx="1508760" cy="502920"/>
+            <a:off x="3412998" y="4114800"/>
+            <a:ext cx="2498598" cy="457200"/>
           </a:xfrm>
           <a:prstGeom prst="rect">
             <a:avLst/>
@@ -7239,14 +6899,14 @@
       </p:sp>
       <p:sp>
         <p:nvSpPr>
-          <p:cNvPr id="40" name="TextBox 39"/>
+          <p:cNvPr id="30" name="TextBox 29"/>
           <p:cNvSpPr txBox="1"/>
           <p:nvPr/>
         </p:nvSpPr>
         <p:spPr>
           <a:xfrm>
-            <a:off x="10522458" y="1481328"/>
-            <a:ext cx="1417319" cy="457200"/>
+            <a:off x="3486150" y="4178808"/>
+            <a:ext cx="2352294" cy="365760"/>
           </a:xfrm>
           <a:prstGeom prst="rect">
             <a:avLst/>
@@ -7261,26 +6921,26 @@
           <a:p>
             <a:pPr algn="ctr"/>
             <a:r>
-              <a:rPr sz="1100" b="1" i="0">
-                <a:solidFill>
-                  <a:srgbClr val="0F3460"/>
-                </a:solidFill>
-              </a:rPr>
-              <a:t>7. Report</a:t>
-            </a:r>
-          </a:p>
-        </p:txBody>
-      </p:sp>
-      <p:sp>
-        <p:nvSpPr>
-          <p:cNvPr id="41" name="TextBox 40"/>
+              <a:rPr sz="1300" b="1" i="0">
+                <a:solidFill>
+                  <a:srgbClr val="0A2240"/>
+                </a:solidFill>
+              </a:rPr>
+              <a:t>5. Summarization</a:t>
+            </a:r>
+          </a:p>
+        </p:txBody>
+      </p:sp>
+      <p:sp>
+        <p:nvSpPr>
+          <p:cNvPr id="31" name="TextBox 30"/>
           <p:cNvSpPr txBox="1"/>
           <p:nvPr/>
         </p:nvSpPr>
         <p:spPr>
           <a:xfrm>
-            <a:off x="10549890" y="2057400"/>
-            <a:ext cx="1362456" cy="3474720"/>
+            <a:off x="3550158" y="4681728"/>
+            <a:ext cx="2224278" cy="1554480"/>
           </a:xfrm>
           <a:prstGeom prst="rect">
             <a:avLst/>
@@ -7295,14 +6955,449 @@
           <a:p>
             <a:pPr algn="ctr"/>
             <a:r>
-              <a:rPr sz="1000" b="0" i="0">
+              <a:rPr sz="1100" b="0" i="0">
                 <a:solidFill>
                   <a:srgbClr val="FFFFFF"/>
                 </a:solidFill>
               </a:rPr>
+              <a:t>Extractive sentence
+ranking via TF-IDF
+ROUGE-1/2/L
+Keyword coverage</a:t>
+            </a:r>
+          </a:p>
+        </p:txBody>
+      </p:sp>
+      <p:sp>
+        <p:nvSpPr>
+          <p:cNvPr id="32" name="Can 31"/>
+          <p:cNvSpPr/>
+          <p:nvPr/>
+        </p:nvSpPr>
+        <p:spPr>
+          <a:xfrm>
+            <a:off x="5888736" y="5047488"/>
+            <a:ext cx="411480" cy="320040"/>
+          </a:xfrm>
+          <a:prstGeom prst="can">
+            <a:avLst/>
+          </a:prstGeom>
+          <a:solidFill>
+            <a:srgbClr val="0F3460"/>
+          </a:solidFill>
+          <a:ln>
+            <a:noFill/>
+          </a:ln>
+        </p:spPr>
+        <p:style>
+          <a:lnRef idx="1">
+            <a:schemeClr val="accent1"/>
+          </a:lnRef>
+          <a:fillRef idx="3">
+            <a:schemeClr val="accent1"/>
+          </a:fillRef>
+          <a:effectRef idx="2">
+            <a:schemeClr val="accent1"/>
+          </a:effectRef>
+          <a:fontRef idx="minor">
+            <a:schemeClr val="lt1"/>
+          </a:fontRef>
+        </p:style>
+        <p:txBody>
+          <a:bodyPr rtlCol="0" anchor="ctr"/>
+          <a:lstStyle/>
+          <a:p>
+            <a:pPr algn="ctr"/>
+          </a:p>
+        </p:txBody>
+      </p:sp>
+      <p:sp>
+        <p:nvSpPr>
+          <p:cNvPr id="33" name="Rectangle 32"/>
+          <p:cNvSpPr/>
+          <p:nvPr/>
+        </p:nvSpPr>
+        <p:spPr>
+          <a:xfrm>
+            <a:off x="6277355" y="4114800"/>
+            <a:ext cx="2498598" cy="2194560"/>
+          </a:xfrm>
+          <a:prstGeom prst="rect">
+            <a:avLst/>
+          </a:prstGeom>
+          <a:solidFill>
+            <a:srgbClr val="0A2240"/>
+          </a:solidFill>
+          <a:ln>
+            <a:noFill/>
+          </a:ln>
+        </p:spPr>
+        <p:style>
+          <a:lnRef idx="1">
+            <a:schemeClr val="accent1"/>
+          </a:lnRef>
+          <a:fillRef idx="3">
+            <a:schemeClr val="accent1"/>
+          </a:fillRef>
+          <a:effectRef idx="2">
+            <a:schemeClr val="accent1"/>
+          </a:effectRef>
+          <a:fontRef idx="minor">
+            <a:schemeClr val="lt1"/>
+          </a:fontRef>
+        </p:style>
+        <p:txBody>
+          <a:bodyPr rtlCol="0" anchor="ctr"/>
+          <a:lstStyle/>
+          <a:p>
+            <a:pPr algn="ctr"/>
+          </a:p>
+        </p:txBody>
+      </p:sp>
+      <p:sp>
+        <p:nvSpPr>
+          <p:cNvPr id="34" name="Rectangle 33"/>
+          <p:cNvSpPr/>
+          <p:nvPr/>
+        </p:nvSpPr>
+        <p:spPr>
+          <a:xfrm>
+            <a:off x="6277355" y="4114800"/>
+            <a:ext cx="2498598" cy="457200"/>
+          </a:xfrm>
+          <a:prstGeom prst="rect">
+            <a:avLst/>
+          </a:prstGeom>
+          <a:solidFill>
+            <a:srgbClr val="E9C46A"/>
+          </a:solidFill>
+          <a:ln>
+            <a:noFill/>
+          </a:ln>
+        </p:spPr>
+        <p:style>
+          <a:lnRef idx="1">
+            <a:schemeClr val="accent1"/>
+          </a:lnRef>
+          <a:fillRef idx="3">
+            <a:schemeClr val="accent1"/>
+          </a:fillRef>
+          <a:effectRef idx="2">
+            <a:schemeClr val="accent1"/>
+          </a:effectRef>
+          <a:fontRef idx="minor">
+            <a:schemeClr val="lt1"/>
+          </a:fontRef>
+        </p:style>
+        <p:txBody>
+          <a:bodyPr rtlCol="0" anchor="ctr"/>
+          <a:lstStyle/>
+          <a:p>
+            <a:pPr algn="ctr"/>
+          </a:p>
+        </p:txBody>
+      </p:sp>
+      <p:sp>
+        <p:nvSpPr>
+          <p:cNvPr id="35" name="TextBox 34"/>
+          <p:cNvSpPr txBox="1"/>
+          <p:nvPr/>
+        </p:nvSpPr>
+        <p:spPr>
+          <a:xfrm>
+            <a:off x="6350507" y="4178808"/>
+            <a:ext cx="2352294" cy="365760"/>
+          </a:xfrm>
+          <a:prstGeom prst="rect">
+            <a:avLst/>
+          </a:prstGeom>
+          <a:noFill/>
+        </p:spPr>
+        <p:txBody>
+          <a:bodyPr wrap="square">
+            <a:spAutoFit/>
+          </a:bodyPr>
+          <a:lstStyle/>
+          <a:p>
+            <a:pPr algn="ctr"/>
+            <a:r>
+              <a:rPr sz="1300" b="1" i="0">
+                <a:solidFill>
+                  <a:srgbClr val="0A2240"/>
+                </a:solidFill>
+              </a:rPr>
+              <a:t>6. Visualization</a:t>
+            </a:r>
+          </a:p>
+        </p:txBody>
+      </p:sp>
+      <p:sp>
+        <p:nvSpPr>
+          <p:cNvPr id="36" name="TextBox 35"/>
+          <p:cNvSpPr txBox="1"/>
+          <p:nvPr/>
+        </p:nvSpPr>
+        <p:spPr>
+          <a:xfrm>
+            <a:off x="6414516" y="4681728"/>
+            <a:ext cx="2224278" cy="1554480"/>
+          </a:xfrm>
+          <a:prstGeom prst="rect">
+            <a:avLst/>
+          </a:prstGeom>
+          <a:noFill/>
+        </p:spPr>
+        <p:txBody>
+          <a:bodyPr wrap="square">
+            <a:spAutoFit/>
+          </a:bodyPr>
+          <a:lstStyle/>
+          <a:p>
+            <a:pPr algn="ctr"/>
+            <a:r>
+              <a:rPr sz="1100" b="0" i="0">
+                <a:solidFill>
+                  <a:srgbClr val="FFFFFF"/>
+                </a:solidFill>
+              </a:rPr>
+              <a:t>t-SNE / PCA 2D
+Metrics bar chart
+Topic heatmap
+Clustering report</a:t>
+            </a:r>
+          </a:p>
+        </p:txBody>
+      </p:sp>
+      <p:sp>
+        <p:nvSpPr>
+          <p:cNvPr id="37" name="Can 36"/>
+          <p:cNvSpPr/>
+          <p:nvPr/>
+        </p:nvSpPr>
+        <p:spPr>
+          <a:xfrm>
+            <a:off x="8753094" y="5047488"/>
+            <a:ext cx="411480" cy="320040"/>
+          </a:xfrm>
+          <a:prstGeom prst="can">
+            <a:avLst/>
+          </a:prstGeom>
+          <a:solidFill>
+            <a:srgbClr val="0F3460"/>
+          </a:solidFill>
+          <a:ln>
+            <a:noFill/>
+          </a:ln>
+        </p:spPr>
+        <p:style>
+          <a:lnRef idx="1">
+            <a:schemeClr val="accent1"/>
+          </a:lnRef>
+          <a:fillRef idx="3">
+            <a:schemeClr val="accent1"/>
+          </a:fillRef>
+          <a:effectRef idx="2">
+            <a:schemeClr val="accent1"/>
+          </a:effectRef>
+          <a:fontRef idx="minor">
+            <a:schemeClr val="lt1"/>
+          </a:fontRef>
+        </p:style>
+        <p:txBody>
+          <a:bodyPr rtlCol="0" anchor="ctr"/>
+          <a:lstStyle/>
+          <a:p>
+            <a:pPr algn="ctr"/>
+          </a:p>
+        </p:txBody>
+      </p:sp>
+      <p:sp>
+        <p:nvSpPr>
+          <p:cNvPr id="38" name="Rectangle 37"/>
+          <p:cNvSpPr/>
+          <p:nvPr/>
+        </p:nvSpPr>
+        <p:spPr>
+          <a:xfrm>
+            <a:off x="9141713" y="4114800"/>
+            <a:ext cx="2498598" cy="2194560"/>
+          </a:xfrm>
+          <a:prstGeom prst="rect">
+            <a:avLst/>
+          </a:prstGeom>
+          <a:solidFill>
+            <a:srgbClr val="0A2240"/>
+          </a:solidFill>
+          <a:ln>
+            <a:noFill/>
+          </a:ln>
+        </p:spPr>
+        <p:style>
+          <a:lnRef idx="1">
+            <a:schemeClr val="accent1"/>
+          </a:lnRef>
+          <a:fillRef idx="3">
+            <a:schemeClr val="accent1"/>
+          </a:fillRef>
+          <a:effectRef idx="2">
+            <a:schemeClr val="accent1"/>
+          </a:effectRef>
+          <a:fontRef idx="minor">
+            <a:schemeClr val="lt1"/>
+          </a:fontRef>
+        </p:style>
+        <p:txBody>
+          <a:bodyPr rtlCol="0" anchor="ctr"/>
+          <a:lstStyle/>
+          <a:p>
+            <a:pPr algn="ctr"/>
+          </a:p>
+        </p:txBody>
+      </p:sp>
+      <p:sp>
+        <p:nvSpPr>
+          <p:cNvPr id="39" name="Rectangle 38"/>
+          <p:cNvSpPr/>
+          <p:nvPr/>
+        </p:nvSpPr>
+        <p:spPr>
+          <a:xfrm>
+            <a:off x="9141713" y="4114800"/>
+            <a:ext cx="2498598" cy="457200"/>
+          </a:xfrm>
+          <a:prstGeom prst="rect">
+            <a:avLst/>
+          </a:prstGeom>
+          <a:solidFill>
+            <a:srgbClr val="E9C46A"/>
+          </a:solidFill>
+          <a:ln>
+            <a:noFill/>
+          </a:ln>
+        </p:spPr>
+        <p:style>
+          <a:lnRef idx="1">
+            <a:schemeClr val="accent1"/>
+          </a:lnRef>
+          <a:fillRef idx="3">
+            <a:schemeClr val="accent1"/>
+          </a:fillRef>
+          <a:effectRef idx="2">
+            <a:schemeClr val="accent1"/>
+          </a:effectRef>
+          <a:fontRef idx="minor">
+            <a:schemeClr val="lt1"/>
+          </a:fontRef>
+        </p:style>
+        <p:txBody>
+          <a:bodyPr rtlCol="0" anchor="ctr"/>
+          <a:lstStyle/>
+          <a:p>
+            <a:pPr algn="ctr"/>
+          </a:p>
+        </p:txBody>
+      </p:sp>
+      <p:sp>
+        <p:nvSpPr>
+          <p:cNvPr id="40" name="TextBox 39"/>
+          <p:cNvSpPr txBox="1"/>
+          <p:nvPr/>
+        </p:nvSpPr>
+        <p:spPr>
+          <a:xfrm>
+            <a:off x="9214865" y="4178808"/>
+            <a:ext cx="2352294" cy="365760"/>
+          </a:xfrm>
+          <a:prstGeom prst="rect">
+            <a:avLst/>
+          </a:prstGeom>
+          <a:noFill/>
+        </p:spPr>
+        <p:txBody>
+          <a:bodyPr wrap="square">
+            <a:spAutoFit/>
+          </a:bodyPr>
+          <a:lstStyle/>
+          <a:p>
+            <a:pPr algn="ctr"/>
+            <a:r>
+              <a:rPr sz="1300" b="1" i="0">
+                <a:solidFill>
+                  <a:srgbClr val="0A2240"/>
+                </a:solidFill>
+              </a:rPr>
+              <a:t>7. Report + Demo</a:t>
+            </a:r>
+          </a:p>
+        </p:txBody>
+      </p:sp>
+      <p:sp>
+        <p:nvSpPr>
+          <p:cNvPr id="41" name="TextBox 40"/>
+          <p:cNvSpPr txBox="1"/>
+          <p:nvPr/>
+        </p:nvSpPr>
+        <p:spPr>
+          <a:xfrm>
+            <a:off x="9278874" y="4681728"/>
+            <a:ext cx="2224278" cy="1554480"/>
+          </a:xfrm>
+          <a:prstGeom prst="rect">
+            <a:avLst/>
+          </a:prstGeom>
+          <a:noFill/>
+        </p:spPr>
+        <p:txBody>
+          <a:bodyPr wrap="square">
+            <a:spAutoFit/>
+          </a:bodyPr>
+          <a:lstStyle/>
+          <a:p>
+            <a:pPr algn="ctr"/>
+            <a:r>
+              <a:rPr sz="1100" b="0" i="0">
+                <a:solidFill>
+                  <a:srgbClr val="FFFFFF"/>
+                </a:solidFill>
+              </a:rPr>
               <a:t>Self-contained HTML
-Base64 embedded imgs
-All metrics</a:t>
++ Streamlit web app
+Group22 PPTX deck
+GitHub repo</a:t>
+            </a:r>
+          </a:p>
+        </p:txBody>
+      </p:sp>
+      <p:sp>
+        <p:nvSpPr>
+          <p:cNvPr id="42" name="TextBox 41"/>
+          <p:cNvSpPr txBox="1"/>
+          <p:nvPr/>
+        </p:nvSpPr>
+        <p:spPr>
+          <a:xfrm>
+            <a:off x="548640" y="6446520"/>
+            <a:ext cx="11064240" cy="365760"/>
+          </a:xfrm>
+          <a:prstGeom prst="rect">
+            <a:avLst/>
+          </a:prstGeom>
+          <a:noFill/>
+        </p:spPr>
+        <p:txBody>
+          <a:bodyPr wrap="square">
+            <a:spAutoFit/>
+          </a:bodyPr>
+          <a:lstStyle/>
+          <a:p>
+            <a:pPr algn="ctr"/>
+            <a:r>
+              <a:rPr sz="1200" b="0" i="1">
+                <a:solidFill>
+                  <a:srgbClr val="555555"/>
+                </a:solidFill>
+              </a:rPr>
+              <a:t>Stages 1-3 build three parallel document representations.  Stages 4-7 cluster, summarise, visualise, and deliver.</a:t>
             </a:r>
           </a:p>
         </p:txBody>
@@ -13064,14 +13159,48 @@
         </p:blipFill>
         <p:spPr>
           <a:xfrm>
-            <a:off x="365760" y="1417320"/>
-            <a:ext cx="11457432" cy="4892040"/>
+            <a:off x="365760" y="2561219"/>
+            <a:ext cx="11457432" cy="2924281"/>
           </a:xfrm>
           <a:prstGeom prst="rect">
             <a:avLst/>
           </a:prstGeom>
         </p:spPr>
       </p:pic>
+      <p:sp>
+        <p:nvSpPr>
+          <p:cNvPr id="9" name="TextBox 8"/>
+          <p:cNvSpPr txBox="1"/>
+          <p:nvPr/>
+        </p:nvSpPr>
+        <p:spPr>
+          <a:xfrm>
+            <a:off x="365760" y="5989320"/>
+            <a:ext cx="11457432" cy="548640"/>
+          </a:xfrm>
+          <a:prstGeom prst="rect">
+            <a:avLst/>
+          </a:prstGeom>
+          <a:noFill/>
+        </p:spPr>
+        <p:txBody>
+          <a:bodyPr wrap="square">
+            <a:spAutoFit/>
+          </a:bodyPr>
+          <a:lstStyle/>
+          <a:p>
+            <a:pPr algn="ctr"/>
+            <a:r>
+              <a:rPr sz="1200" b="0" i="1">
+                <a:solidFill>
+                  <a:srgbClr val="555555"/>
+                </a:solidFill>
+              </a:rPr>
+              <a:t>Each panel shows a 2D t-SNE projection of patents, colored by cluster.  TF-IDF and LDA produce visibly tighter, more separable clusters than SBERT on this corpus.</a:t>
+            </a:r>
+          </a:p>
+        </p:txBody>
+      </p:sp>
     </p:spTree>
   </p:cSld>
   <p:clrMapOvr>
@@ -13337,8 +13466,8 @@
         </p:blipFill>
         <p:spPr>
           <a:xfrm>
-            <a:off x="640080" y="1417320"/>
-            <a:ext cx="10908792" cy="4892040"/>
+            <a:off x="1188651" y="1463040"/>
+            <a:ext cx="9811649" cy="4846320"/>
           </a:xfrm>
           <a:prstGeom prst="rect">
             <a:avLst/>

</xml_diff>